<commit_message>
Guarda los errores del navegador en la base para poder leerlos
Co-Authored-By: Claude Fable 5.1 <noreply@anthropic.com>
</commit_message>
<xml_diff>
--- a/contenido/claude-en-tu-empresa/sesion-1/entregables/sesion-1-alineacion.pptx
+++ b/contenido/claude-en-tu-empresa/sesion-1/entregables/sesion-1-alineacion.pptx
@@ -243,7 +243,7 @@
           <a:p>
             <a:fld id="{72E89F2E-8888-4E3E-971F-EDA368EF51AE}" type="datetimeFigureOut">
               <a:rPr lang="es-MX" smtClean="0"/>
-              <a:t>20/09/2026</a:t>
+              <a:t>21/09/2026</a:t>
             </a:fld>
             <a:endParaRPr lang="es-MX"/>
           </a:p>
@@ -2704,7 +2704,7 @@
           <a:p>
             <a:fld id="{5BCAD085-E8A6-8845-BD4E-CB4CCA059FC4}" type="datetimeFigureOut">
               <a:rPr lang="en-US" smtClean="0"/>
-              <a:t>9/20/2026</a:t>
+              <a:t>9/21/2026</a:t>
             </a:fld>
             <a:endParaRPr lang="en-US"/>
           </a:p>
@@ -2872,7 +2872,7 @@
           <a:p>
             <a:fld id="{5BCAD085-E8A6-8845-BD4E-CB4CCA059FC4}" type="datetimeFigureOut">
               <a:rPr lang="en-US" smtClean="0"/>
-              <a:t>9/20/2026</a:t>
+              <a:t>9/21/2026</a:t>
             </a:fld>
             <a:endParaRPr lang="en-US"/>
           </a:p>
@@ -3050,7 +3050,7 @@
           <a:p>
             <a:fld id="{5BCAD085-E8A6-8845-BD4E-CB4CCA059FC4}" type="datetimeFigureOut">
               <a:rPr lang="en-US" smtClean="0"/>
-              <a:t>9/20/2026</a:t>
+              <a:t>9/21/2026</a:t>
             </a:fld>
             <a:endParaRPr lang="en-US"/>
           </a:p>
@@ -3218,7 +3218,7 @@
           <a:p>
             <a:fld id="{5BCAD085-E8A6-8845-BD4E-CB4CCA059FC4}" type="datetimeFigureOut">
               <a:rPr lang="en-US" smtClean="0"/>
-              <a:t>9/20/2026</a:t>
+              <a:t>9/21/2026</a:t>
             </a:fld>
             <a:endParaRPr lang="en-US"/>
           </a:p>
@@ -3463,7 +3463,7 @@
           <a:p>
             <a:fld id="{5BCAD085-E8A6-8845-BD4E-CB4CCA059FC4}" type="datetimeFigureOut">
               <a:rPr lang="en-US" smtClean="0"/>
-              <a:t>9/20/2026</a:t>
+              <a:t>9/21/2026</a:t>
             </a:fld>
             <a:endParaRPr lang="en-US"/>
           </a:p>
@@ -3748,7 +3748,7 @@
           <a:p>
             <a:fld id="{5BCAD085-E8A6-8845-BD4E-CB4CCA059FC4}" type="datetimeFigureOut">
               <a:rPr lang="en-US" smtClean="0"/>
-              <a:t>9/20/2026</a:t>
+              <a:t>9/21/2026</a:t>
             </a:fld>
             <a:endParaRPr lang="en-US"/>
           </a:p>
@@ -4167,7 +4167,7 @@
           <a:p>
             <a:fld id="{5BCAD085-E8A6-8845-BD4E-CB4CCA059FC4}" type="datetimeFigureOut">
               <a:rPr lang="en-US" smtClean="0"/>
-              <a:t>9/20/2026</a:t>
+              <a:t>9/21/2026</a:t>
             </a:fld>
             <a:endParaRPr lang="en-US"/>
           </a:p>
@@ -4284,7 +4284,7 @@
           <a:p>
             <a:fld id="{5BCAD085-E8A6-8845-BD4E-CB4CCA059FC4}" type="datetimeFigureOut">
               <a:rPr lang="en-US" smtClean="0"/>
-              <a:t>9/20/2026</a:t>
+              <a:t>9/21/2026</a:t>
             </a:fld>
             <a:endParaRPr lang="en-US"/>
           </a:p>
@@ -4379,7 +4379,7 @@
           <a:p>
             <a:fld id="{5BCAD085-E8A6-8845-BD4E-CB4CCA059FC4}" type="datetimeFigureOut">
               <a:rPr lang="en-US" smtClean="0"/>
-              <a:t>9/20/2026</a:t>
+              <a:t>9/21/2026</a:t>
             </a:fld>
             <a:endParaRPr lang="en-US"/>
           </a:p>
@@ -4654,7 +4654,7 @@
           <a:p>
             <a:fld id="{5BCAD085-E8A6-8845-BD4E-CB4CCA059FC4}" type="datetimeFigureOut">
               <a:rPr lang="en-US" smtClean="0"/>
-              <a:t>9/20/2026</a:t>
+              <a:t>9/21/2026</a:t>
             </a:fld>
             <a:endParaRPr lang="en-US"/>
           </a:p>
@@ -4906,7 +4906,7 @@
           <a:p>
             <a:fld id="{5BCAD085-E8A6-8845-BD4E-CB4CCA059FC4}" type="datetimeFigureOut">
               <a:rPr lang="en-US" smtClean="0"/>
-              <a:t>9/20/2026</a:t>
+              <a:t>9/21/2026</a:t>
             </a:fld>
             <a:endParaRPr lang="en-US"/>
           </a:p>
@@ -5117,7 +5117,7 @@
           <a:p>
             <a:fld id="{5BCAD085-E8A6-8845-BD4E-CB4CCA059FC4}" type="datetimeFigureOut">
               <a:rPr lang="en-US" smtClean="0"/>
-              <a:t>9/20/2026</a:t>
+              <a:t>9/21/2026</a:t>
             </a:fld>
             <a:endParaRPr lang="en-US"/>
           </a:p>
@@ -11676,24 +11676,6 @@
                 </a:solidFill>
                 <a:latin typeface="Inter"/>
               </a:rPr>
-              <a:t/>
-            </a:r>
-            <a:r>
-              <a:rPr lang="es-MX" sz="1600" b="0" dirty="0" err="1">
-                <a:solidFill>
-                  <a:srgbClr val="4E6572"/>
-                </a:solidFill>
-                <a:latin typeface="Inter"/>
-              </a:rPr>
-              <a:t/>
-            </a:r>
-            <a:r>
-              <a:rPr lang="es-MX" sz="1600" b="0" dirty="0">
-                <a:solidFill>
-                  <a:srgbClr val="4E6572"/>
-                </a:solidFill>
-                <a:latin typeface="Inter"/>
-              </a:rPr>
               <a:t> más</a:t>
             </a:r>
             <a:r>
@@ -12438,15 +12420,6 @@
               </a:rPr>
               <a:t>¿Cuánto vas TU A INVERTIR EN TI?</a:t>
             </a:r>
-            <a:r>
-              <a:rPr sz="1800" b="0" dirty="0">
-                <a:solidFill>
-                  <a:srgbClr val="072835"/>
-                </a:solidFill>
-                <a:latin typeface="Inter"/>
-              </a:rPr>
-              <a:t/>
-            </a:r>
           </a:p>
         </p:txBody>
       </p:sp>
@@ -17792,15 +17765,6 @@
                 <a:latin typeface="Inter"/>
               </a:rPr>
               <a:t>1.- Criterios</a:t>
-            </a:r>
-            <a:r>
-              <a:rPr sz="1800" b="0" dirty="0" err="1">
-                <a:solidFill>
-                  <a:srgbClr val="072835"/>
-                </a:solidFill>
-                <a:latin typeface="Inter"/>
-              </a:rPr>
-              <a:t/>
             </a:r>
             <a:r>
               <a:rPr sz="1800" b="0" dirty="0">
@@ -20760,15 +20724,6 @@
                 <a:latin typeface="Inter"/>
               </a:rPr>
               <a:t>grupal</a:t>
-            </a:r>
-            <a:r>
-              <a:rPr sz="1200" b="0" dirty="0">
-                <a:solidFill>
-                  <a:srgbClr val="FFFFFF"/>
-                </a:solidFill>
-                <a:latin typeface="Inter"/>
-              </a:rPr>
-              <a:t/>
             </a:r>
           </a:p>
         </p:txBody>
@@ -26900,12 +26855,6 @@
               </a:rPr>
               <a:t>.</a:t>
             </a:r>
-            <a:endParaRPr sz="3200" b="0" dirty="0">
-              <a:solidFill>
-                <a:srgbClr val="0A1728"/>
-              </a:solidFill>
-              <a:latin typeface="Inter"/>
-            </a:endParaRPr>
           </a:p>
         </p:txBody>
       </p:sp>
@@ -27315,7 +27264,9 @@
         <p:txBody>
           <a:bodyPr rtlCol="0" anchor="ctr"/>
           <a:lstStyle/>
-          <a:p/>
+          <a:p>
+            <a:endParaRPr/>
+          </a:p>
         </p:txBody>
       </p:sp>
       <p:sp>
@@ -27335,7 +27286,7 @@
           <a:noFill/>
         </p:spPr>
         <p:txBody>
-          <a:bodyPr wrap="none" anchor="t" lIns="0" tIns="0" rIns="0" bIns="0">
+          <a:bodyPr wrap="none" lIns="0" tIns="0" rIns="0" bIns="0" anchor="t">
             <a:spAutoFit/>
           </a:bodyPr>
           <a:lstStyle/>
@@ -27352,25 +27303,7 @@
                 </a:solidFill>
                 <a:latin typeface="Anton"/>
               </a:rPr>
-              <a:t>QUIÉNES TE </a:t>
-            </a:r>
-            <a:r>
-              <a:rPr sz="6800" b="0">
-                <a:solidFill>
-                  <a:srgbClr val="0A1A2F"/>
-                </a:solidFill>
-                <a:latin typeface="Anton"/>
-              </a:rPr>
-              <a:t>ACOMPAÑAN</a:t>
-            </a:r>
-            <a:r>
-              <a:rPr sz="6800" b="0">
-                <a:solidFill>
-                  <a:srgbClr val="0A1A2F"/>
-                </a:solidFill>
-                <a:latin typeface="Anton"/>
-              </a:rPr>
-              <a:t>.</a:t>
+              <a:t>QUIÉNES TE ACOMPAÑAN.</a:t>
             </a:r>
           </a:p>
         </p:txBody>
@@ -27416,7 +27349,9 @@
         <p:txBody>
           <a:bodyPr rtlCol="0" anchor="ctr"/>
           <a:lstStyle/>
-          <a:p/>
+          <a:p>
+            <a:endParaRPr/>
+          </a:p>
         </p:txBody>
       </p:sp>
       <p:sp>
@@ -27436,7 +27371,7 @@
           <a:noFill/>
         </p:spPr>
         <p:txBody>
-          <a:bodyPr wrap="none" anchor="t" lIns="0" tIns="0" rIns="0" bIns="0">
+          <a:bodyPr wrap="none" lIns="0" tIns="0" rIns="0" bIns="0" anchor="t">
             <a:spAutoFit/>
           </a:bodyPr>
           <a:lstStyle/>
@@ -27497,7 +27432,7 @@
           </a:fontRef>
         </p:style>
         <p:txBody>
-          <a:bodyPr rtlCol="0" anchor="ctr" wrap="none" lIns="114300" rIns="114300" tIns="0" bIns="0"/>
+          <a:bodyPr wrap="none" lIns="114300" tIns="0" rIns="114300" bIns="0" rtlCol="0" anchor="ctr"/>
           <a:lstStyle/>
           <a:p>
             <a:r>
@@ -27529,7 +27464,7 @@
           <a:noFill/>
         </p:spPr>
         <p:txBody>
-          <a:bodyPr wrap="square" anchor="t" lIns="0" tIns="0" rIns="0" bIns="0">
+          <a:bodyPr wrap="square" lIns="0" tIns="0" rIns="0" bIns="0" anchor="t">
             <a:spAutoFit/>
           </a:bodyPr>
           <a:lstStyle/>
@@ -27564,7 +27499,7 @@
           <a:noFill/>
         </p:spPr>
         <p:txBody>
-          <a:bodyPr wrap="square" anchor="t" lIns="0" tIns="0" rIns="0" bIns="0">
+          <a:bodyPr wrap="square" lIns="0" tIns="0" rIns="0" bIns="0" anchor="t">
             <a:spAutoFit/>
           </a:bodyPr>
           <a:lstStyle/>
@@ -27623,7 +27558,9 @@
         <p:txBody>
           <a:bodyPr rtlCol="0" anchor="ctr"/>
           <a:lstStyle/>
-          <a:p/>
+          <a:p>
+            <a:endParaRPr/>
+          </a:p>
         </p:txBody>
       </p:sp>
       <p:sp>
@@ -27643,7 +27580,7 @@
           <a:noFill/>
         </p:spPr>
         <p:txBody>
-          <a:bodyPr wrap="none" anchor="t" lIns="0" tIns="0" rIns="0" bIns="0">
+          <a:bodyPr wrap="none" lIns="0" tIns="0" rIns="0" bIns="0" anchor="t">
             <a:spAutoFit/>
           </a:bodyPr>
           <a:lstStyle/>
@@ -27704,7 +27641,7 @@
           </a:fontRef>
         </p:style>
         <p:txBody>
-          <a:bodyPr rtlCol="0" anchor="ctr" wrap="none" lIns="114300" rIns="114300" tIns="0" bIns="0"/>
+          <a:bodyPr wrap="none" lIns="114300" tIns="0" rIns="114300" bIns="0" rtlCol="0" anchor="ctr"/>
           <a:lstStyle/>
           <a:p>
             <a:r>
@@ -27736,7 +27673,7 @@
           <a:noFill/>
         </p:spPr>
         <p:txBody>
-          <a:bodyPr wrap="square" anchor="t" lIns="0" tIns="0" rIns="0" bIns="0">
+          <a:bodyPr wrap="square" lIns="0" tIns="0" rIns="0" bIns="0" anchor="t">
             <a:spAutoFit/>
           </a:bodyPr>
           <a:lstStyle/>
@@ -27771,7 +27708,7 @@
           <a:noFill/>
         </p:spPr>
         <p:txBody>
-          <a:bodyPr wrap="square" anchor="t" lIns="0" tIns="0" rIns="0" bIns="0">
+          <a:bodyPr wrap="square" lIns="0" tIns="0" rIns="0" bIns="0" anchor="t">
             <a:spAutoFit/>
           </a:bodyPr>
           <a:lstStyle/>
@@ -27830,7 +27767,9 @@
         <p:txBody>
           <a:bodyPr rtlCol="0" anchor="ctr"/>
           <a:lstStyle/>
-          <a:p/>
+          <a:p>
+            <a:endParaRPr/>
+          </a:p>
         </p:txBody>
       </p:sp>
       <p:sp>
@@ -27850,7 +27789,7 @@
           <a:noFill/>
         </p:spPr>
         <p:txBody>
-          <a:bodyPr wrap="none" anchor="t" lIns="0" tIns="0" rIns="0" bIns="0">
+          <a:bodyPr wrap="none" lIns="0" tIns="0" rIns="0" bIns="0" anchor="t">
             <a:spAutoFit/>
           </a:bodyPr>
           <a:lstStyle/>
@@ -27911,7 +27850,7 @@
           </a:fontRef>
         </p:style>
         <p:txBody>
-          <a:bodyPr rtlCol="0" anchor="ctr" wrap="none" lIns="114300" rIns="114300" tIns="0" bIns="0"/>
+          <a:bodyPr wrap="none" lIns="114300" tIns="0" rIns="114300" bIns="0" rtlCol="0" anchor="ctr"/>
           <a:lstStyle/>
           <a:p>
             <a:r>
@@ -27943,7 +27882,7 @@
           <a:noFill/>
         </p:spPr>
         <p:txBody>
-          <a:bodyPr wrap="square" anchor="t" lIns="0" tIns="0" rIns="0" bIns="0">
+          <a:bodyPr wrap="square" lIns="0" tIns="0" rIns="0" bIns="0" anchor="t">
             <a:spAutoFit/>
           </a:bodyPr>
           <a:lstStyle/>
@@ -27978,7 +27917,7 @@
           <a:noFill/>
         </p:spPr>
         <p:txBody>
-          <a:bodyPr wrap="square" anchor="t" lIns="0" tIns="0" rIns="0" bIns="0">
+          <a:bodyPr wrap="square" lIns="0" tIns="0" rIns="0" bIns="0" anchor="t">
             <a:spAutoFit/>
           </a:bodyPr>
           <a:lstStyle/>

</xml_diff>